<commit_message>
Diagnóstico de Mesoescala: caso granizo gigante em Florianópolis (28/08/2026)
</commit_message>
<xml_diff>
--- a/apresentacao_meso.pptx
+++ b/apresentacao_meso.pptx
@@ -532,7 +532,7 @@
           </a:p>
           <a:p>
             <a:r>
-              <a:t>Essas sondagens podem ser escolhidas em datas diferentes na mesma estação — como fizemos para Porto Alegre (SBPA - 83971) em dezembro de 1995 — ou em estações diferentes.</a:t>
+              <a:t>Essas sondagens podem ser escolhidas em datas diferentes na mesma estação — como fizemos para Florianópolis (SBFL - 83899) em agosto de 2026 — ou em estações diferentes.</a:t>
             </a:r>
           </a:p>
           <a:p/>
@@ -623,17 +623,17 @@
           </a:p>
           <a:p>
             <a:r>
-              <a:t>1. O caso de 12/12 foi caracterizado por ausência de instabilidade (SBCAPE de 16 J/kg) e ar seco.</a:t>
-            </a:r>
-          </a:p>
-          <a:p>
-            <a:r>
-              <a:t>2. O caso de 22/12 apresentou umidade intermediária e SBCAPE moderado (836 J/kg), com inibição convectiva significativa (-221.8 J/kg).</a:t>
-            </a:r>
-          </a:p>
-          <a:p>
-            <a:r>
-              <a:t>3. O caso de 24/12 reuniu alto teor de vapor (55.3 mm), vento intenso em baixos níveis (44 kt em 925 hPa), bulk shear 0-6 km de 12.6 m/s e helicidade SRH 0-3 km de -123.3 m²/s² com o vetor Bunkers Left-Mover relevante para o Hemisfério Sul.</a:t>
+              <a:t>1. O caso de 26/08 foi caracterizado por ausência de instabilidade (SBCAPE de 8 J/kg) e ar seco.</a:t>
+            </a:r>
+          </a:p>
+          <a:p>
+            <a:r>
+              <a:t>2. O caso de 31/08 apresentou umidade intermediária e SBCAPE moderado (0 J/kg), com inibição convectiva significativa (0.0 J/kg).</a:t>
+            </a:r>
+          </a:p>
+          <a:p>
+            <a:r>
+              <a:t>3. O caso de 28/08 reuniu alto teor de vapor (40.9 mm), vento intenso em baixos níveis (20 kt em 925 hPa), bulk shear 0-6 km de 20.5 m/s e helicidade SRH 0-3 km de -336.3 m²/s² com o vetor Bunkers Left-Mover relevante para o Hemisfério Sul.</a:t>
             </a:r>
           </a:p>
           <a:p/>
@@ -714,7 +714,7 @@
           </a:p>
           <a:p>
             <a:r>
-              <a:t>Passando à análise do ambiente sinótico e dinâmico de 24 de dezembro de 1995 às 12Z.</a:t>
+              <a:t>Passando à análise do ambiente sinótico e dinâmico de 28 de agosto de 2026 às 12Z.</a:t>
             </a:r>
           </a:p>
           <a:p>
@@ -725,12 +725,12 @@
           <a:p/>
           <a:p>
             <a:r>
-              <a:t>Os dados observados na própria radiossondagem de Porto Alegre atestam a presença de suporte dinâmico e termodinâmico relevante:</a:t>
-            </a:r>
-          </a:p>
-          <a:p>
-            <a:r>
-              <a:t>Em 925 hPa, registrou-se vento de 44 nós (22.6 m/s) de quadrante ENE, indicando forte escoamento nos baixos níveis transportando umidade (PW de 55.3 mm).</a:t>
+              <a:t>Os dados observados na própria radiossondagem de Florianópolis atestam a presença de suporte dinâmico e termodinâmico relevante:</a:t>
+            </a:r>
+          </a:p>
+          <a:p>
+            <a:r>
+              <a:t>Em 925 hPa, registrou-se vento de 20 nós (10.3 m/s) de quadrante ENE, indicando forte escoamento nos baixos níveis transportando umidade (PW de 40.9 mm).</a:t>
             </a:r>
           </a:p>
           <a:p>
@@ -816,12 +816,12 @@
           <a:p/>
           <a:p>
             <a:r>
-              <a:t>Na ANÁLISE 1 (12/12/1995 12Z - Estável):</a:t>
-            </a:r>
-          </a:p>
-          <a:p>
-            <a:r>
-              <a:t>A atmosfera observada exibe forte ar seco em médios níveis. O SBCAPE calculado é de apenas 15.7 J/kg e MUCAPE de 0.9 J/kg, com água precipitável de 35.1 mm.</a:t>
+              <a:t>Na ANÁLISE 1 (26/08/2026 12Z - Estável):</a:t>
+            </a:r>
+          </a:p>
+          <a:p>
+            <a:r>
+              <a:t>A atmosfera observada exibe forte ar seco em médios níveis. O SBCAPE calculado é de apenas 8.1 J/kg e MUCAPE de 0.0 J/kg, com água precipitável de 27.1 mm.</a:t>
             </a:r>
           </a:p>
           <a:p>
@@ -832,12 +832,12 @@
           <a:p/>
           <a:p>
             <a:r>
-              <a:t>Na ANÁLISE 2 (22/12/1995 12Z - Neutra):</a:t>
-            </a:r>
-          </a:p>
-          <a:p>
-            <a:r>
-              <a:t>A sondagem de 22/12 representa o regime neutro, intermediário entre o estável e o instável. O SBCAPE e MUCAPE são de 836.0 J/kg, acompanhados por moderada inibição convectiva (SBCIN = -221.8 J/kg) e água precipitável de 43.9 mm. O cisalhamento 0-6 km é de 2.8 m/s. Trata-se de um caso clássico de equilíbrio condicional.</a:t>
+              <a:t>Na ANÁLISE 2 (31/08/2026 12Z - Neutra):</a:t>
+            </a:r>
+          </a:p>
+          <a:p>
+            <a:r>
+              <a:t>A sondagem de 31/08 representa o regime neutro, intermediário entre o estável e o instável. O SBCAPE e MUCAPE são de 0.0 J/kg, acompanhados por moderada inibição convectiva (SBCIN = 0.0 J/kg) e água precipitável de 45.8 mm. O cisalhamento 0-6 km é de 31.9 m/s. Trata-se de um caso clássico de equilíbrio condicional.</a:t>
             </a:r>
           </a:p>
         </p:txBody>
@@ -912,12 +912,12 @@
           </a:p>
           <a:p>
             <a:r>
-              <a:t>No Skew-T à esquerda, gerado via MetPy pelo script auditado, observamos o perfil do dia 24/12/1995 12Z.</a:t>
-            </a:r>
-          </a:p>
-          <a:p>
-            <a:r>
-              <a:t>Na sondagem completa oficial, o MUCAPE calculado atinge 7810.0 J/kg, originado na camada quente e úmida de 925 hPa (T = 30°C, Td = 25°C). O SBCAPE é de 1861.9 J/kg com SBCIN de -186.3 J/kg.</a:t>
+              <a:t>No Skew-T à esquerda, gerado via MetPy pelo script auditado, observamos o perfil do dia 28/08/2026 12Z.</a:t>
+            </a:r>
+          </a:p>
+          <a:p>
+            <a:r>
+              <a:t>Na sondagem completa oficial, o MUCAPE calculado atinge 1303.5 J/kg, originado na camada quente e úmida de 925 hPa (T = 30°C, Td = 25°C). O SBCAPE é de 442.8 J/kg com SBCIN de -280.0 J/kg.</a:t>
             </a:r>
           </a:p>
           <a:p/>
@@ -928,7 +928,7 @@
           </a:p>
           <a:p>
             <a:r>
-              <a:t>Ao realizarmos um teste de sensibilidade sem esses níveis específicos, o MUCAPE resultante passa a ser 1860.1 J/kg e o SBCAPE 1860.1 J/kg.</a:t>
+              <a:t>Ao realizarmos um teste de sensibilidade sem esses níveis específicos, o MUCAPE resultante passa a ser 1109.5 J/kg e o SBCAPE 446.4 J/kg.</a:t>
             </a:r>
           </a:p>
           <a:p>
@@ -1029,17 +1029,17 @@
           </a:p>
           <a:p>
             <a:r>
-              <a:t>No dia 12/12 (Estável), os valores são quase nulos (22.5 J/kg pseudoadiabático).</a:t>
-            </a:r>
-          </a:p>
-          <a:p>
-            <a:r>
-              <a:t>No dia 22/12, há empuxo moderado (503.4 J/kg pseudoadiabático e -107.7 J/kg reversível).</a:t>
-            </a:r>
-          </a:p>
-          <a:p>
-            <a:r>
-              <a:t>No dia 24/12, a parcela de superfície fornece 1480.2 J/kg (pseudo) e 402.4 J/kg (rev), enquanto o nível de 925 hPa sustenta valores máximos de 7782.1 J/kg e 6247.8 J/kg.</a:t>
+              <a:t>No dia 26/08 (Estável), os valores são quase nulos (10.3 J/kg pseudoadiabático).</a:t>
+            </a:r>
+          </a:p>
+          <a:p>
+            <a:r>
+              <a:t>No dia 31/08, há empuxo moderado (0.0 J/kg pseudoadiabático e 0.0 J/kg reversível).</a:t>
+            </a:r>
+          </a:p>
+          <a:p>
+            <a:r>
+              <a:t>No dia 28/08, a parcela de superfície fornece 57.4 J/kg (pseudo) e -557.4 J/kg (rev), enquanto o nível de 925 hPa sustenta valores máximos de 57.4 J/kg e 0.0 J/kg.</a:t>
             </a:r>
           </a:p>
         </p:txBody>
@@ -1119,7 +1119,7 @@
           </a:p>
           <a:p>
             <a:r>
-              <a:t>O Painel 1 exibe a temperatura potencial equivalente (θe): no dia 24/12, a camada abaixo de 600 hPa exibe decréscimo vertical acentuado (∂θe/∂z &lt; 0), caracterizando instabilidade potencial profunda.</a:t>
+              <a:t>O Painel 1 exibe a temperatura potencial equivalente (θe): no dia 28/08, a camada abaixo de 600 hPa exibe decréscimo vertical acentuado (∂θe/∂z &lt; 0), caracterizando instabilidade potencial profunda.</a:t>
             </a:r>
           </a:p>
           <a:p>
@@ -1129,7 +1129,7 @@
           </a:p>
           <a:p>
             <a:r>
-              <a:t>Os Painéis 3 e 4 confirmam a estabilidade estática e a alta concentração de umidade (PW de 55.3 mm).</a:t>
+              <a:t>Os Painéis 3 e 4 confirmam a estabilidade estática e a alta concentração de umidade (PW de 40.9 mm).</a:t>
             </a:r>
           </a:p>
         </p:txBody>
@@ -1209,7 +1209,7 @@
           </a:p>
           <a:p>
             <a:r>
-              <a:t>O conteúdo de água precipitável (PW) é de 55.3 mm pela sondagem completa e 50.8 mm no teste de sensibilidade.</a:t>
+              <a:t>O conteúdo de água precipitável (PW) é de 40.9 mm pela sondagem completa e 40.2 mm no teste de sensibilidade.</a:t>
             </a:r>
           </a:p>
           <a:p>
@@ -1219,17 +1219,17 @@
           </a:p>
           <a:p>
             <a:r>
-              <a:t>1. Wyoming (página INDICES): 1149.0 J/kg.</a:t>
-            </a:r>
-          </a:p>
-          <a:p>
-            <a:r>
-              <a:t>2. MetPy (mpcalc.downdraft_cape, coluna integrada): 1096.8 J/kg.</a:t>
-            </a:r>
-          </a:p>
-          <a:p>
-            <a:r>
-              <a:t>3. Kerry Emanuel (1994, cape.out, máximo sobre as origens): 60.7 J/kg a partir de 905 hPa (0.0 J/kg na superfície).</a:t>
+              <a:t>1. Wyoming (página INDICES): 1189.7 J/kg.</a:t>
+            </a:r>
+          </a:p>
+          <a:p>
+            <a:r>
+              <a:t>2. MetPy (mpcalc.downdraft_cape, coluna integrada): 1217.1 J/kg.</a:t>
+            </a:r>
+          </a:p>
+          <a:p>
+            <a:r>
+              <a:t>3. Kerry Emanuel (1994, cape.out, máximo sobre as origens): 47.3 J/kg a partir de 905 hPa (0.0 J/kg na superfície).</a:t>
             </a:r>
           </a:p>
           <a:p>
@@ -1314,18 +1314,18 @@
           </a:p>
           <a:p>
             <a:r>
-              <a:t>O gráfico à esquerda é o hodógrafo polar gerado via MetPy a partir dos dados auditados de 24/12/1995 12Z.</a:t>
-            </a:r>
-          </a:p>
-          <a:p>
-            <a:r>
-              <a:t>Em 925 hPa, o vento atinge 44 nós (22.6 m/s) de direção 60°, gerando acentuada curvatura na baixa troposfera.</a:t>
+              <a:t>O gráfico à esquerda é o hodógrafo polar gerado via MetPy a partir dos dados auditados de 28/08/2026 12Z.</a:t>
+            </a:r>
+          </a:p>
+          <a:p>
+            <a:r>
+              <a:t>Em 925 hPa, o vento atinge 20 nós (10.3 m/s) de direção 340°, gerando acentuada curvatura na baixa troposfera.</a:t>
             </a:r>
           </a:p>
           <a:p/>
           <a:p>
             <a:r>
-              <a:t>O cisalhamento vertical profundo (Bulk Shear 0-6 km) calculado pelo MetPy é de 12.6 m/s (24.5 kt).</a:t>
+              <a:t>O cisalhamento vertical profundo (Bulk Shear 0-6 km) calculado pelo MetPy é de 20.5 m/s (39.4 kt).</a:t>
             </a:r>
           </a:p>
           <a:p>
@@ -1335,7 +1335,7 @@
           </a:p>
           <a:p>
             <a:r>
-              <a:t>O cálculo rigoroso com MetPy fornece um vetor Bunkers LM de (-4.4, -3.9) m/s, resultando em SRH 0-1 km de -105.3 m²/s² e SRH 0-3 km de -123.3 m²/s².</a:t>
+              <a:t>O cálculo rigoroso com MetPy fornece um vetor Bunkers LM de (12.4, -3.9) m/s, resultando em SRH 0-1 km de -180.9 m²/s² e SRH 0-3 km de -336.3 m²/s².</a:t>
             </a:r>
           </a:p>
         </p:txBody>
@@ -4661,7 +4661,7 @@
               </a:defRPr>
             </a:pPr>
             <a:r>
-              <a:t>Investigação Comparativa das 3 Sondagens de Porto Alegre (SBPA - 83971) e Algoritmos de Kerry Emanuel (1994)</a:t>
+              <a:t>Temporal Severo com Granizo Gigante em Florianópolis (SBFL - 83899) em 28/08/2026 e Algoritmos de Kerry Emanuel (1994)</a:t>
             </a:r>
           </a:p>
         </p:txBody>
@@ -4756,19 +4756,19 @@
               </a:defRPr>
             </a:pPr>
             <a:r>
-              <a:t>1. Estável: 12/12/1995 12Z</a:t>
+              <a:t>1. Estável: 26/08/2026 12Z</a:t>
             </a:r>
             <a:br/>
             <a:r>
-              <a:t>2. Neutra: 22/12/1995 12Z</a:t>
+              <a:t>2. Neutra: 31/08/2026 12Z</a:t>
             </a:r>
             <a:br/>
             <a:r>
-              <a:t>3. Instável: 24/12/1995 12Z</a:t>
+              <a:t>3. Instável: 28/08/2026 12Z</a:t>
             </a:r>
             <a:br/>
             <a:r>
-              <a:t>Estação: SBPA (Porto Alegre)</a:t>
+              <a:t>Estação: SBFL (Florianópolis)</a:t>
             </a:r>
           </a:p>
         </p:txBody>
@@ -5355,7 +5355,7 @@
                   <a:srgbClr val="F87171"/>
                 </a:solidFill>
               </a:rPr>
-              <a:t>12/12: 16 | 22/12: 836 | 24/12: 1862</a:t>
+              <a:t>26/08: 8 | 31/08: 0 | 28/08: 443</a:t>
             </a:r>
           </a:p>
           <a:p>
@@ -5378,7 +5378,7 @@
                   <a:srgbClr val="F87171"/>
                 </a:solidFill>
               </a:rPr>
-              <a:t>12/12: 1 | 22/12: 836 | 24/12: 7810 (Sensibilidade: 1860)</a:t>
+              <a:t>26/08: 0 | 31/08: 267 | 28/08: 1304 (Sensibilidade: 1110)</a:t>
             </a:r>
           </a:p>
           <a:p>
@@ -5401,7 +5401,7 @@
                   <a:srgbClr val="38BDF8"/>
                 </a:solidFill>
               </a:rPr>
-              <a:t>12/12: 0.0 | 22/12: -221.8 | 24/12: -186.3</a:t>
+              <a:t>26/08: 0.0 | 31/08: 0.0 | 28/08: -280.0</a:t>
             </a:r>
           </a:p>
           <a:p>
@@ -5424,7 +5424,7 @@
                   <a:srgbClr val="38BDF8"/>
                 </a:solidFill>
               </a:rPr>
-              <a:t>12/12: 35.1 mm | 22/12: 43.9 mm | 24/12: 55.3 mm</a:t>
+              <a:t>26/08: 27.1 mm | 31/08: 45.8 mm | 28/08: 40.9 mm</a:t>
             </a:r>
           </a:p>
           <a:p>
@@ -5447,7 +5447,7 @@
                   <a:srgbClr val="FBBF24"/>
                 </a:solidFill>
               </a:rPr>
-              <a:t>12/12: 9 kt | 22/12: 9 kt | 24/12: 44 kt (22.6 m/s)</a:t>
+              <a:t>26/08: 18 kt | 31/08: 9 kt | 28/08: 20 kt (10.3 m/s)</a:t>
             </a:r>
           </a:p>
           <a:p>
@@ -5470,7 +5470,7 @@
                   <a:srgbClr val="34D399"/>
                 </a:solidFill>
               </a:rPr>
-              <a:t>12/12: 13.7 m/s | 22/12: 2.8 m/s | 24/12: 12.6 m/s</a:t>
+              <a:t>26/08: 15.8 m/s | 31/08: 31.9 m/s | 28/08: 20.5 m/s</a:t>
             </a:r>
           </a:p>
           <a:p>
@@ -5493,7 +5493,7 @@
                   <a:srgbClr val="34D399"/>
                 </a:solidFill>
               </a:rPr>
-              <a:t>12/12: -52.2 | 22/12: -5.2 | 24/12: -123.3</a:t>
+              <a:t>26/08: -24.0 | 31/08: -174.7 | 28/08: -336.3</a:t>
             </a:r>
           </a:p>
           <a:p>
@@ -5516,7 +5516,7 @@
                   <a:srgbClr val="F8FAFC"/>
                 </a:solidFill>
               </a:rPr>
-              <a:t>12/12: 644 | 22/12: 1352 | 24/12: 1149</a:t>
+              <a:t>26/08: 614 | 31/08: 634 | 28/08: 1190</a:t>
             </a:r>
           </a:p>
           <a:p>
@@ -5539,7 +5539,7 @@
                   <a:srgbClr val="F8FAFC"/>
                 </a:solidFill>
               </a:rPr>
-              <a:t>12/12: 643 | 22/12: 1338 | 24/12: 1097</a:t>
+              <a:t>26/08: 588 | 31/08: 636 | 28/08: 1217</a:t>
             </a:r>
           </a:p>
           <a:p>
@@ -5562,7 +5562,7 @@
                   <a:srgbClr val="F8FAFC"/>
                 </a:solidFill>
               </a:rPr>
-              <a:t>12/12: 60.0 | 22/12: 195.4 | 24/12: 60.7</a:t>
+              <a:t>26/08: 47.3 | 31/08: 4.9 | 28/08: 47.3</a:t>
             </a:r>
           </a:p>
           <a:p>
@@ -6112,24 +6112,24 @@
             </a:r>
             <a:br/>
             <a:r>
-              <a:t>• A integração de cartas reais de reanálise (ERA5 ou NCEP de 24/12/1995 12Z) será definida com a orientação do professor.</a:t>
+              <a:t>• A integração de cartas reais de reanálise (ERA5 ou NCEP de 28/08/2026 12Z) será definida com a orientação do professor.</a:t>
             </a:r>
             <a:br/>
             <a:br/>
             <a:r>
-              <a:t>Evidências Observacionais na Radiossondagem (SBPA):</a:t>
+              <a:t>Evidências Observacionais na Radiossondagem (SBFL):</a:t>
             </a:r>
             <a:br/>
             <a:r>
-              <a:t>• Vento em 925 hPa: 44 kt (22.6 m/s) de 60° (ENE).</a:t>
+              <a:t>• Vento em 925 hPa: 20 kt (10.3 m/s) de 340° (ENE).</a:t>
             </a:r>
             <a:br/>
             <a:r>
-              <a:t>• Água Precipitável Total (PW): 55.3 mm.</a:t>
+              <a:t>• Água Precipitável Total (PW): 40.9 mm.</a:t>
             </a:r>
             <a:br/>
             <a:r>
-              <a:t>• Cisalhamento 0-6 km: 12.6 m/s (24.5 kt).</a:t>
+              <a:t>• Cisalhamento 0-6 km: 20.5 m/s (39.4 kt).</a:t>
             </a:r>
           </a:p>
         </p:txBody>
@@ -6227,7 +6227,7 @@
               </a:defRPr>
             </a:pPr>
             <a:r>
-              <a:t>• A radiossondagem pontual em SBPA registra perfil termodinâmico vertical local e cisalhamento.</a:t>
+              <a:t>• A radiossondagem pontual em SBFL registra perfil termodinâmico vertical local e cisalhamento.</a:t>
             </a:r>
           </a:p>
           <a:p>
@@ -6272,7 +6272,7 @@
               </a:defRPr>
             </a:pPr>
             <a:r>
-              <a:t>• Vento intenso observado em 925 hPa: 44 kt (22.6 m/s) de 60° (ENE).</a:t>
+              <a:t>• Vento intenso observado em 925 hPa: 20 kt (10.3 m/s) de 340° (ENE).</a:t>
             </a:r>
           </a:p>
           <a:p>
@@ -6287,7 +6287,7 @@
               </a:defRPr>
             </a:pPr>
             <a:r>
-              <a:t>• Transporte de umidade na camada limite com PW = 55.3 mm.</a:t>
+              <a:t>• Transporte de umidade na camada limite com PW = 40.9 mm.</a:t>
             </a:r>
           </a:p>
           <a:p>
@@ -6517,7 +6517,7 @@
               </a:defRPr>
             </a:pPr>
             <a:r>
-              <a:t>As Três Sondagens &amp; Três Análises: Estável (12/12) vs Neutra (22/12)</a:t>
+              <a:t>As Três Sondagens &amp; Três Análises: Estável (26/08) vs Neutra (31/08)</a:t>
             </a:r>
           </a:p>
         </p:txBody>
@@ -6574,7 +6574,7 @@
         <p:spPr>
           <a:xfrm>
             <a:off x="731520" y="1600200"/>
-            <a:ext cx="6583680" cy="2099178"/>
+            <a:ext cx="6583680" cy="2097719"/>
           </a:xfrm>
           <a:prstGeom prst="rect">
             <a:avLst/>
@@ -6659,7 +6659,7 @@
               </a:defRPr>
             </a:pPr>
             <a:r>
-              <a:t>ANÁLISE 1: Atmosfera Estável (12/12/1995 12Z)</a:t>
+              <a:t>ANÁLISE 1: Atmosfera Estável (26/08/2026 12Z)</a:t>
             </a:r>
           </a:p>
           <a:p>
@@ -6689,7 +6689,7 @@
               </a:defRPr>
             </a:pPr>
             <a:r>
-              <a:t>• Termodinâmica MetPy: SBCAPE = 15.7 J/kg; MUCAPE = 0.9 J/kg; PW = 35.1 mm.</a:t>
+              <a:t>• Termodinâmica MetPy: SBCAPE = 8.1 J/kg; MUCAPE = 0.0 J/kg; PW = 27.1 mm.</a:t>
             </a:r>
           </a:p>
           <a:p>
@@ -6704,7 +6704,7 @@
               </a:defRPr>
             </a:pPr>
             <a:r>
-              <a:t>• Emanuel (1994): CAPE reversível = 16.9 J/kg; pseudo = 22.5 J/kg.</a:t>
+              <a:t>• Emanuel (1994): CAPE reversível = -3.9 J/kg; pseudo = 10.3 J/kg.</a:t>
             </a:r>
           </a:p>
           <a:p>
@@ -6719,7 +6719,7 @@
               </a:defRPr>
             </a:pPr>
             <a:r>
-              <a:t>• Cinemática: Cisalhamento 0-6 km = 13.7 m/s (26.6 kt); SRH 0-3km LM = -52.2 m²/s².</a:t>
+              <a:t>• Cinemática: Cisalhamento 0-6 km = 15.8 m/s (32.0 kt); SRH 0-3km LM = -24.0 m²/s².</a:t>
             </a:r>
           </a:p>
           <a:p>
@@ -6734,7 +6734,7 @@
               </a:defRPr>
             </a:pPr>
             <a:r>
-              <a:t>ANÁLISE 2: Caso Neutro / Mod. Instável (22/12/1995 12Z)</a:t>
+              <a:t>ANÁLISE 2: Caso Neutro / Mod. Instável (31/08/2026 12Z)</a:t>
             </a:r>
           </a:p>
           <a:p>
@@ -6764,7 +6764,7 @@
               </a:defRPr>
             </a:pPr>
             <a:r>
-              <a:t>• Termodinâmica Auditada: SBCAPE = 836.0 J/kg; MUCAPE = 836.0 J/kg; SBCIN = -221.8 J/kg; PW = 43.9 mm.</a:t>
+              <a:t>• Termodinâmica Auditada: SBCAPE = 0.0 J/kg; MUCAPE = 267.1 J/kg; SBCIN = 0.0 J/kg; PW = 45.8 mm.</a:t>
             </a:r>
           </a:p>
           <a:p>
@@ -6779,7 +6779,7 @@
               </a:defRPr>
             </a:pPr>
             <a:r>
-              <a:t>• Emanuel (1994): CAPE reversível = -107.7 J/kg; pseudo = 503.4 J/kg; DCAPE máx = 195.4 J/kg.</a:t>
+              <a:t>• Emanuel (1994): CAPE reversível = 0.0 J/kg; pseudo = 0.0 J/kg; DCAPE máx = 4.9 J/kg.</a:t>
             </a:r>
           </a:p>
           <a:p>
@@ -6794,7 +6794,7 @@
               </a:defRPr>
             </a:pPr>
             <a:r>
-              <a:t>• Cinemática: Cisalhamento 0-6 km = 2.8 m/s (5.5 kt); SRH 0-3km LM = -5.2 m²/s².</a:t>
+              <a:t>• Cinemática: Cisalhamento 0-6 km = 31.9 m/s (67.0 kt); SRH 0-3km LM = -174.7 m²/s².</a:t>
             </a:r>
           </a:p>
           <a:p>
@@ -6809,7 +6809,7 @@
               </a:defRPr>
             </a:pPr>
             <a:r>
-              <a:t>• Nota de Classificação: Regime neutro: empuxo moderado (SBCAPE = 836 J/kg) com expressiva inibição convectiva (SBCIN = -221.8 J/kg) que impede convecção espontânea sem forçamento dinâmico.</a:t>
+              <a:t>• Nota de Classificação: Regime neutro: empuxo moderado (SBCAPE = 0 J/kg) com expressiva inibição convectiva (SBCIN = 0.0 J/kg) que impede convecção espontânea sem forçamento dinâmico.</a:t>
             </a:r>
           </a:p>
         </p:txBody>
@@ -6994,7 +6994,7 @@
               </a:defRPr>
             </a:pPr>
             <a:r>
-              <a:t>As Três Sondagens &amp; Três Análises: Atmosfera Instável (24/12) &amp; Teste de Sensibilidade</a:t>
+              <a:t>As Três Sondagens &amp; Três Análises: Atmosfera Instável (28/08) &amp; Teste de Sensibilidade</a:t>
             </a:r>
           </a:p>
         </p:txBody>
@@ -7136,7 +7136,7 @@
               </a:defRPr>
             </a:pPr>
             <a:r>
-              <a:t>ANÁLISE 3: Atmosfera Instável (24/12/1995 12Z - Sondagem Completa)</a:t>
+              <a:t>ANÁLISE 3: Atmosfera Instável (28/08/2026 12Z - Sondagem Completa)</a:t>
             </a:r>
           </a:p>
           <a:p>
@@ -7151,7 +7151,7 @@
               </a:defRPr>
             </a:pPr>
             <a:r>
-              <a:t>• Sondagem Completa (Oficial): SBCAPE = 1861.9 J/kg | MUCAPE = 7810.0 J/kg | MLCAPE = 3447.0 J/kg.</a:t>
+              <a:t>• Sondagem Completa (Oficial): SBCAPE = 442.8 J/kg | MUCAPE = 1303.5 J/kg | MLCAPE = 48.5 J/kg.</a:t>
             </a:r>
           </a:p>
           <a:p>
@@ -7166,7 +7166,7 @@
               </a:defRPr>
             </a:pPr>
             <a:r>
-              <a:t>• SBCIN = -186.3 J/kg | PW = 55.3 mm | LCL = 988.4 hPa.</a:t>
+              <a:t>• SBCIN = -280.0 J/kg | PW = 40.9 mm | LCL = 973.4 hPa.</a:t>
             </a:r>
           </a:p>
           <a:p>
@@ -7181,7 +7181,7 @@
               </a:defRPr>
             </a:pPr>
             <a:r>
-              <a:t>• Vento em 925 hPa: 44 kt (22.6 m/s) de 60°.</a:t>
+              <a:t>• Vento em 925 hPa: 20 kt (10.3 m/s) de 340°.</a:t>
             </a:r>
           </a:p>
           <a:p>
@@ -7241,7 +7241,7 @@
               </a:defRPr>
             </a:pPr>
             <a:r>
-              <a:t>• Teste de Sensibilidade (sem níveis próximos a 925 hPa): MUCAPE = 1860.1 J/kg | SBCAPE = 1860.1 J/kg | PW = 50.8 mm.</a:t>
+              <a:t>• Teste de Sensibilidade (sem níveis próximos a 925 hPa): MUCAPE = 1109.5 J/kg | SBCAPE = 446.4 J/kg | PW = 40.2 mm.</a:t>
             </a:r>
           </a:p>
           <a:p>
@@ -7286,7 +7286,7 @@
               </a:defRPr>
             </a:pPr>
             <a:r>
-              <a:t>• • Estável (12/12): SBCAPE = 15.7 J/kg | Shear 0-6km = 13.7 m/s</a:t>
+              <a:t>• • Estável (26/08): SBCAPE = 8.1 J/kg | Shear 0-6km = 15.8 m/s</a:t>
             </a:r>
           </a:p>
           <a:p>
@@ -7301,7 +7301,7 @@
               </a:defRPr>
             </a:pPr>
             <a:r>
-              <a:t>• • Neutra (22/12): SBCAPE = 836.0 J/kg | Shear 0-6km = 2.8 m/s</a:t>
+              <a:t>• • Neutra (31/08): SBCAPE = 0.0 J/kg | Shear 0-6km = 31.9 m/s</a:t>
             </a:r>
           </a:p>
           <a:p>
@@ -7316,7 +7316,7 @@
               </a:defRPr>
             </a:pPr>
             <a:r>
-              <a:t>• • Instável (24/12): SBCAPE = 1861.9 J/kg | Shear 0-6km = 12.6 m/s</a:t>
+              <a:t>• • Instável (28/08): SBCAPE = 442.8 J/kg | Shear 0-6km = 20.5 m/s</a:t>
             </a:r>
           </a:p>
         </p:txBody>
@@ -7558,7 +7558,7 @@
         <p:spPr>
           <a:xfrm>
             <a:off x="731520" y="1600200"/>
-            <a:ext cx="6583680" cy="4525961"/>
+            <a:ext cx="6583680" cy="4504892"/>
           </a:xfrm>
           <a:prstGeom prst="rect">
             <a:avLst/>
@@ -7763,7 +7763,7 @@
               </a:defRPr>
             </a:pPr>
             <a:r>
-              <a:t>• 12/12 (Estável): Tρ negativo em quase toda a coluna. CAPE rev = 16.9 J/kg; pseudo = 22.5 J/kg.</a:t>
+              <a:t>• 26/08 (Estável): Tρ negativo em quase toda a coluna. CAPE rev = -3.9 J/kg; pseudo = 10.3 J/kg.</a:t>
             </a:r>
           </a:p>
           <a:p>
@@ -7778,7 +7778,7 @@
               </a:defRPr>
             </a:pPr>
             <a:r>
-              <a:t>• 22/12 (Neutra): Camada de empuxo positiva moderada. CAPE rev = -107.7 J/kg; pseudo = 503.4 J/kg.</a:t>
+              <a:t>• 31/08 (Neutra): Camada de empuxo positiva moderada. CAPE rev = 0.0 J/kg; pseudo = 0.0 J/kg.</a:t>
             </a:r>
           </a:p>
           <a:p>
@@ -7793,7 +7793,7 @@
               </a:defRPr>
             </a:pPr>
             <a:r>
-              <a:t>• 24/12 (Instável): Na superfície, CAPE rev = 402.4 J/kg vs pseudo = 1480.2 J/kg. No pico de 925 hPa, atinge 6247.8 J/kg (rev) e 7782.1 J/kg (pseudo).</a:t>
+              <a:t>• 28/08 (Instável): Na superfície, CAPE rev = -557.4 J/kg vs pseudo = 57.4 J/kg. No pico de 925 hPa, atinge 0.0 J/kg (rev) e 57.4 J/kg (pseudo).</a:t>
             </a:r>
           </a:p>
         </p:txBody>
@@ -8013,7 +8013,7 @@
               </a:defRPr>
             </a:pPr>
             <a:r>
-              <a:t>Comparação dos Três Regimes Atmosféricos em Porto Alegre (SBPA - 83971) - Topo em 200 hPa</a:t>
+              <a:t>Comparação dos Três Regimes Atmosféricos em Florianópolis (SBFL - 83899) - Topo em 200 hPa</a:t>
             </a:r>
           </a:p>
         </p:txBody>
@@ -8035,7 +8035,7 @@
         <p:spPr>
           <a:xfrm>
             <a:off x="731520" y="1600200"/>
-            <a:ext cx="6583680" cy="4011086"/>
+            <a:ext cx="6583680" cy="4004683"/>
           </a:xfrm>
           <a:prstGeom prst="rect">
             <a:avLst/>
@@ -8135,7 +8135,7 @@
               </a:defRPr>
             </a:pPr>
             <a:r>
-              <a:t>• Superfície: 12/12 = 319.3 K | 22/12 = 343.8 K | 24/12 = 377.8 K (em 925 hPa).</a:t>
+              <a:t>• Superfície: 26/08 = 319.2 K | 31/08 = 326.9 K | 28/08 = 333.9 K (em 925 hPa).</a:t>
             </a:r>
           </a:p>
           <a:p>
@@ -8150,7 +8150,7 @@
               </a:defRPr>
             </a:pPr>
             <a:r>
-              <a:t>• Instabilidade Convectiva: Camada com ∂θe/∂z &lt; 0 bem estabelecida nos dias 22 e 24/12.</a:t>
+              <a:t>• Instabilidade Convectiva: Camada com ∂θe/∂z &lt; 0 bem estabelecida nos dias 22 e 28/08.</a:t>
             </a:r>
           </a:p>
           <a:p>
@@ -8195,7 +8195,7 @@
               </a:defRPr>
             </a:pPr>
             <a:r>
-              <a:t>• No caso de 24/12, camada com N² elevado próximo a 925 hPa denota forte estabilidade estática local.</a:t>
+              <a:t>• No caso de 28/08, camada com N² elevado próximo a 925 hPa denota forte estabilidade estática local.</a:t>
             </a:r>
           </a:p>
           <a:p>
@@ -8255,7 +8255,7 @@
               </a:defRPr>
             </a:pPr>
             <a:r>
-              <a:t>• Razão de mistura máxima em 24/12 atinge 22.0 g/kg em 925 hPa.</a:t>
+              <a:t>• Razão de mistura máxima em 28/08 atinge 22.0 g/kg em 925 hPa.</a:t>
             </a:r>
           </a:p>
           <a:p>
@@ -8270,7 +8270,7 @@
               </a:defRPr>
             </a:pPr>
             <a:r>
-              <a:t>• Água Precipitável Total (PW): 55.3 mm no dia 24/12 vs 35.1 mm no dia 12/12.</a:t>
+              <a:t>• Água Precipitável Total (PW): 40.9 mm no dia 28/08 vs 27.1 mm no dia 26/08.</a:t>
             </a:r>
           </a:p>
         </p:txBody>
@@ -8490,7 +8490,7 @@
               </a:defRPr>
             </a:pPr>
             <a:r>
-              <a:t>Perfis de θ, θe, θs, Brunt-Väisälä N², Umidade e DCAPE para 24/12/1995 12Z</a:t>
+              <a:t>Perfis de θ, θe, θs, Brunt-Väisälä N², Umidade e DCAPE para 28/08/2026 12Z</a:t>
             </a:r>
           </a:p>
         </p:txBody>
@@ -8512,7 +8512,7 @@
         <p:spPr>
           <a:xfrm>
             <a:off x="731520" y="1600200"/>
-            <a:ext cx="6583680" cy="2718096"/>
+            <a:ext cx="6583680" cy="2725391"/>
           </a:xfrm>
           <a:prstGeom prst="rect">
             <a:avLst/>
@@ -8672,7 +8672,7 @@
               </a:defRPr>
             </a:pPr>
             <a:r>
-              <a:t>• PW calculado via MetPy: 55.3 mm (Sondagem completa) / 50.8 mm (Sensibilidade).</a:t>
+              <a:t>• PW calculado via MetPy: 40.9 mm (Sondagem completa) / 40.2 mm (Sensibilidade).</a:t>
             </a:r>
           </a:p>
           <a:p>
@@ -8717,7 +8717,7 @@
               </a:defRPr>
             </a:pPr>
             <a:r>
-              <a:t>Downdraft CAPE (DCAPE) - Três Métodos para 24/12:</a:t>
+              <a:t>Downdraft CAPE (DCAPE) - Três Métodos para 28/08:</a:t>
             </a:r>
           </a:p>
           <a:p>
@@ -8732,7 +8732,7 @@
               </a:defRPr>
             </a:pPr>
             <a:r>
-              <a:t>• 1. Wyoming (Página INDICES): 1149.0 J/kg.</a:t>
+              <a:t>• 1. Wyoming (Página INDICES): 1189.7 J/kg.</a:t>
             </a:r>
           </a:p>
           <a:p>
@@ -8747,7 +8747,7 @@
               </a:defRPr>
             </a:pPr>
             <a:r>
-              <a:t>• 2. MetPy (mpcalc.downdraft_cape): 1096.8 J/kg (coluna a partir do mín. θe).</a:t>
+              <a:t>• 2. MetPy (mpcalc.downdraft_cape): 1217.1 J/kg (coluna a partir do mín. θe).</a:t>
             </a:r>
           </a:p>
           <a:p>
@@ -8762,7 +8762,7 @@
               </a:defRPr>
             </a:pPr>
             <a:r>
-              <a:t>• 3. Emanuel (cape.out, máx. sobre origens): 60.7 J/kg (origem em 905 hPa; 0.0 J/kg na SFC).</a:t>
+              <a:t>• 3. Emanuel (cape.out, máx. sobre origens): 47.3 J/kg (origem em 905 hPa; 0.0 J/kg na SFC).</a:t>
             </a:r>
           </a:p>
           <a:p>
@@ -9019,7 +9019,7 @@
         <p:spPr>
           <a:xfrm>
             <a:off x="731520" y="1600200"/>
-            <a:ext cx="6583680" cy="6702725"/>
+            <a:ext cx="6583680" cy="6718783"/>
           </a:xfrm>
           <a:prstGeom prst="rect">
             <a:avLst/>
@@ -9119,7 +9119,7 @@
               </a:defRPr>
             </a:pPr>
             <a:r>
-              <a:t>• Intensidade: 44 kt (22.6 m/s) de direção 60° (ENE).</a:t>
+              <a:t>• Intensidade: 20 kt (10.3 m/s) de direção 340° (ENE).</a:t>
             </a:r>
           </a:p>
           <a:p>
@@ -9179,7 +9179,7 @@
               </a:defRPr>
             </a:pPr>
             <a:r>
-              <a:t>• 0-1 km: 19.7 m/s (38.4 kt).</a:t>
+              <a:t>• 0-1 km: 8.5 m/s (27.0 kt).</a:t>
             </a:r>
           </a:p>
           <a:p>
@@ -9194,7 +9194,7 @@
               </a:defRPr>
             </a:pPr>
             <a:r>
-              <a:t>• 0-3 km: 8.4 m/s (16.3 kt).</a:t>
+              <a:t>• 0-3 km: 18.2 m/s (35.4 kt).</a:t>
             </a:r>
           </a:p>
           <a:p>
@@ -9209,7 +9209,7 @@
               </a:defRPr>
             </a:pPr>
             <a:r>
-              <a:t>• 0-6 km: 12.6 m/s (24.5 kt) [Auditado via MetPy].</a:t>
+              <a:t>• 0-6 km: 20.5 m/s (39.4 kt) [Auditado via MetPy].</a:t>
             </a:r>
           </a:p>
           <a:p>
@@ -9239,7 +9239,7 @@
               </a:defRPr>
             </a:pPr>
             <a:r>
-              <a:t>• Vetor Bunkers LM: (-4.4, -3.9) m/s [11.4 kt de 48°].</a:t>
+              <a:t>• Vetor Bunkers LM: (12.4, -3.9) m/s [25.3 kt de 288°].</a:t>
             </a:r>
           </a:p>
           <a:p>
@@ -9254,7 +9254,7 @@
               </a:defRPr>
             </a:pPr>
             <a:r>
-              <a:t>• SRH 0-1 km (LM): -105.3 m²/s².</a:t>
+              <a:t>• SRH 0-1 km (LM): -180.9 m²/s².</a:t>
             </a:r>
           </a:p>
           <a:p>
@@ -9269,7 +9269,7 @@
               </a:defRPr>
             </a:pPr>
             <a:r>
-              <a:t>• SRH 0-3 km (LM): -123.3 m²/s².</a:t>
+              <a:t>• SRH 0-3 km (LM): -336.3 m²/s².</a:t>
             </a:r>
           </a:p>
           <a:p>

</xml_diff>

<commit_message>
Remove agradecimentos do slide 10 e corrige abas de Emanuel no site
- generate_pptx.py / apresentacao_meso.pptx: sem 'Fechamento & Agradecimentos'
  no slide 10 nem o agradecimento nas notas do orador.
- build_index_html.py / index.html: as abas Estavel/Neutra/Instavel mostravam
  as matrizes de Porto Alegre (83971) de 1995; agora usam emanuel_20260826,
  emanuel_20260831 e emanuel_20260828 (SBFL 83899).

Co-Authored-By: Claude Opus 5.5 <noreply@anthropic.com>
</commit_message>
<xml_diff>
--- a/apresentacao_meso.pptx
+++ b/apresentacao_meso.pptx
@@ -639,7 +639,7 @@
           <a:p/>
           <a:p>
             <a:r>
-              <a:t>Agradeço ao Professor Reinaldo Haas e aos previsores da Defesa Civil de SC. Concluo no tempo regulamentar e coloco-me à disposição para a discussão técnica e operacional.</a:t>
+              <a:t>Concluo no tempo regulamentar e coloco-me à disposição para a discussão técnica e operacional.</a:t>
             </a:r>
           </a:p>
         </p:txBody>
@@ -5748,32 +5748,12 @@
               <a:spcBef>
                 <a:spcPts val="1000"/>
               </a:spcBef>
-              <a:defRPr sz="1150" b="1">
-                <a:solidFill>
-                  <a:srgbClr val="34D399"/>
-                </a:solidFill>
-              </a:defRPr>
-            </a:pPr>
-            <a:r>
-              <a:t>Fechamento &amp; Agradecimentos:</a:t>
-            </a:r>
-          </a:p>
-          <a:p>
-            <a:pPr>
-              <a:spcBef>
-                <a:spcPts val="300"/>
-              </a:spcBef>
               <a:defRPr sz="950">
                 <a:solidFill>
                   <a:srgbClr val="F8FAFC"/>
                 </a:solidFill>
               </a:defRPr>
             </a:pPr>
-            <a:r>
-              <a:t>Agradeço ao Professor Dr. Reinaldo Haas pela orientação acadêmica e aos previsores da Defesa Civil de SC pela atenção técnica dispensada.</a:t>
-            </a:r>
-            <a:br/>
-            <a:br/>
             <a:r>
               <a:t>O código-fonte completo (notebook, wyoming.f, tarefa_sondagens.py/.m, calc_metricas.py, generate_figures.py e tutorial interativo) encontra-se disponível no repositório GitHub:</a:t>
             </a:r>

</xml_diff>